<commit_message>
update ressources and PPT template
</commit_message>
<xml_diff>
--- a/Slides_AntoineSoetewey_Beamm.Conf26.pptx
+++ b/Slides_AntoineSoetewey_Beamm.Conf26.pptx
@@ -106,6 +106,11 @@
       </a:defRPr>
     </a:lvl9pPr>
   </p:defaultTextStyle>
+  <p:extLst>
+    <p:ext uri="{EFAFB233-063F-42B5-8137-9DF3F51BA10A}">
+      <p15:sldGuideLst xmlns:p15="http://schemas.microsoft.com/office/powerpoint/2012/main"/>
+    </p:ext>
+  </p:extLst>
 </p:presentation>
 </file>
 
@@ -3866,8 +3871,12 @@
           <a:lstStyle/>
           <a:p>
             <a:r>
+              <a:rPr lang="fr-FR"/>
+              <a:t>Beamm.Conf26</a:t>
+            </a:r>
+            <a:r>
               <a:rPr lang="fr-FR" dirty="0"/>
-              <a:t>June 30, 2026</a:t>
+              <a:t>, June 30 2026</a:t>
             </a:r>
           </a:p>
         </p:txBody>

</xml_diff>